<commit_message>
Reflect deployed-image gate, wrapper repro, portable kit & ops learnings across docs & deck
- Outbound gate = 3 checks: reproduce at the real output stage (the wrapper
  that rebuilds the contract, not internal extract()) -> local JSON match ->
  verify inside the deployed image (WORKFLOW/EJEMPLO_REAL/herramientas.md +
  both guides + deck slides 13/15)
- ai-agent-methodology: the method is a portable starter-kit (templates +
  bootstrap) to take the guardrails to another repo / GitHub Copilot
  (metodologia/README + guides + deck slide 12)
- machine-sync: WSL USB manual mount, byte-exact copy verify, ~0.9->1.5GB
  bundle growth, repo-list drift (machine-sync.md + guides + deck slide 16)
- deck regenerated (build_pptx.py -> Claude_Code_Presentacion.pptx, 20 slides)

Co-Authored-By: Claude Opus 4.8 (1M context) <noreply@anthropic.com>
</commit_message>
<xml_diff>
--- a/presentacion/Claude_Code_Presentacion.pptx
+++ b/presentacion/Claude_Code_Presentacion.pptx
@@ -6771,7 +6771,61 @@
       </p:sp>
       <p:sp>
         <p:nvSpPr>
-          <p:cNvPr id="17" name="Rounded Rectangle 16"/>
+          <p:cNvPr id="17" name="TextBox 16"/>
+          <p:cNvSpPr txBox="1"/>
+          <p:nvPr/>
+        </p:nvSpPr>
+        <p:spPr>
+          <a:xfrm>
+            <a:off x="658368" y="5138928"/>
+            <a:ext cx="10881360" cy="457200"/>
+          </a:xfrm>
+          <a:prstGeom prst="rect">
+            <a:avLst/>
+          </a:prstGeom>
+          <a:noFill/>
+        </p:spPr>
+        <p:txBody>
+          <a:bodyPr wrap="square" anchor="t" lIns="0" rIns="0" tIns="0" bIns="0">
+            <a:spAutoFit/>
+          </a:bodyPr>
+          <a:lstStyle/>
+          <a:p>
+            <a:pPr algn="l">
+              <a:lnSpc>
+                <a:spcPct val="103000"/>
+              </a:lnSpc>
+              <a:spcBef>
+                <a:spcPts val="0"/>
+              </a:spcBef>
+              <a:spcAft>
+                <a:spcPts val="400"/>
+              </a:spcAft>
+            </a:pPr>
+            <a:r>
+              <a:rPr sz="1150" b="1">
+                <a:solidFill>
+                  <a:srgbClr val="D97757"/>
+                </a:solidFill>
+                <a:latin typeface="Segoe UI"/>
+              </a:rPr>
+              <a:t>Portable:  </a:t>
+            </a:r>
+            <a:r>
+              <a:rPr sz="1100" b="0">
+                <a:solidFill>
+                  <a:srgbClr val="9AA4B2"/>
+                </a:solidFill>
+                <a:latin typeface="Segoe UI"/>
+              </a:rPr>
+              <a:t>el método se empaqueta como un starter-kit (plantillas + bootstrap) para llevarlo a otro repo o a GitHub Copilot — la disciplina es agnóstica de la herramienta.</a:t>
+            </a:r>
+          </a:p>
+        </p:txBody>
+      </p:sp>
+      <p:sp>
+        <p:nvSpPr>
+          <p:cNvPr id="18" name="Rounded Rectangle 17"/>
           <p:cNvSpPr/>
           <p:nvPr/>
         </p:nvSpPr>
@@ -6819,7 +6873,7 @@
       </p:sp>
       <p:sp>
         <p:nvSpPr>
-          <p:cNvPr id="18" name="Rounded Rectangle 17"/>
+          <p:cNvPr id="19" name="Rounded Rectangle 18"/>
           <p:cNvSpPr/>
           <p:nvPr/>
         </p:nvSpPr>
@@ -6865,7 +6919,7 @@
       </p:sp>
       <p:sp>
         <p:nvSpPr>
-          <p:cNvPr id="19" name="TextBox 18"/>
+          <p:cNvPr id="20" name="TextBox 19"/>
           <p:cNvSpPr txBox="1"/>
           <p:nvPr/>
         </p:nvSpPr>
@@ -8539,7 +8593,7 @@
                 </a:solidFill>
                 <a:latin typeface="Segoe UI"/>
               </a:rPr>
-              <a:t>Verificar + gate outbound (contrato)</a:t>
+              <a:t>Verificar: contrato (wrapper) + imagen desplegada</a:t>
             </a:r>
           </a:p>
         </p:txBody>
@@ -12512,7 +12566,7 @@
                 </a:solidFill>
                 <a:latin typeface="Segoe UI"/>
               </a:rPr>
-              <a:t>Test RED → fix por propiedad estructural (no cliente) → regresión byte-idéntica + contrato local.</a:t>
+              <a:t>Test RED → fix estructural (no cliente) → regresión no-op + contrato local (wrapper) + dentro de la imagen desplegada.</a:t>
             </a:r>
           </a:p>
         </p:txBody>
@@ -13197,7 +13251,7 @@
         <p:spPr>
           <a:xfrm>
             <a:off x="640080" y="1828800"/>
-            <a:ext cx="5349240" cy="2377440"/>
+            <a:ext cx="5349240" cy="2468880"/>
           </a:xfrm>
           <a:prstGeom prst="roundRect">
             <a:avLst>
@@ -13290,7 +13344,7 @@
         <p:spPr>
           <a:xfrm>
             <a:off x="914400" y="2487168"/>
-            <a:ext cx="4846320" cy="1554480"/>
+            <a:ext cx="4846320" cy="1645920"/>
           </a:xfrm>
           <a:prstGeom prst="rect">
             <a:avLst/>
@@ -13393,6 +13447,37 @@
                 <a:latin typeface="Segoe UI"/>
               </a:rPr>
               <a:t>Excluye venvs / node_modules / caches / .codegraph</a:t>
+            </a:r>
+          </a:p>
+          <a:p>
+            <a:pPr algn="l">
+              <a:lnSpc>
+                <a:spcPct val="105000"/>
+              </a:lnSpc>
+              <a:spcBef>
+                <a:spcPts val="0"/>
+              </a:spcBef>
+              <a:spcAft>
+                <a:spcPts val="600"/>
+              </a:spcAft>
+            </a:pPr>
+            <a:r>
+              <a:rPr sz="1150" b="1">
+                <a:solidFill>
+                  <a:srgbClr val="7AA2C7"/>
+                </a:solidFill>
+                <a:latin typeface="Segoe UI"/>
+              </a:rPr>
+              <a:t>▸  </a:t>
+            </a:r>
+            <a:r>
+              <a:rPr sz="1150" b="0">
+                <a:solidFill>
+                  <a:srgbClr val="E8EAED"/>
+                </a:solidFill>
+                <a:latin typeface="Segoe UI"/>
+              </a:rPr>
+              <a:t>USB: mount manual en WSL + verificar byte a byte</a:t>
             </a:r>
           </a:p>
           <a:p>
@@ -13437,7 +13522,7 @@
         <p:spPr>
           <a:xfrm>
             <a:off x="6217920" y="1828800"/>
-            <a:ext cx="5349240" cy="2377440"/>
+            <a:ext cx="5349240" cy="2468880"/>
           </a:xfrm>
           <a:prstGeom prst="roundRect">
             <a:avLst>
@@ -13530,7 +13615,7 @@
         <p:spPr>
           <a:xfrm>
             <a:off x="6492240" y="2487168"/>
-            <a:ext cx="4846320" cy="1554480"/>
+            <a:ext cx="4846320" cy="1645920"/>
           </a:xfrm>
           <a:prstGeom prst="rect">
             <a:avLst/>
@@ -13676,7 +13761,7 @@
         </p:nvSpPr>
         <p:spPr>
           <a:xfrm>
-            <a:off x="640080" y="4343400"/>
+            <a:off x="640080" y="4407408"/>
             <a:ext cx="10927080" cy="1280160"/>
           </a:xfrm>
           <a:prstGeom prst="roundRect">
@@ -13724,7 +13809,7 @@
         </p:nvSpPr>
         <p:spPr>
           <a:xfrm>
-            <a:off x="914400" y="4544568"/>
+            <a:off x="914400" y="4608576"/>
             <a:ext cx="10469880" cy="365760"/>
           </a:xfrm>
           <a:prstGeom prst="rect">
@@ -13769,7 +13854,7 @@
         </p:nvSpPr>
         <p:spPr>
           <a:xfrm>
-            <a:off x="914400" y="5001768"/>
+            <a:off x="914400" y="5065776"/>
             <a:ext cx="10424159" cy="457199"/>
           </a:xfrm>
           <a:prstGeom prst="rect">

</xml_diff>